<commit_message>
docs(deck-v2.1): pooled 50-shop pilot power, A9 profit CI rule, EN author-checked status, plain capability tiles, Q4 cap-refusal Q&A, and P1 Stage 2 plan [skip render]
</commit_message>
<xml_diff>
--- a/deck/v2/PaytmAI_VyaparVoice_v2.pptx
+++ b/deck/v2/PaytmAI_VyaparVoice_v2.pptx
@@ -587,7 +587,7 @@
           <a:lstStyle/>
           <a:p>
             <a:r>
-              <a:t>Appendix A5 reflects all Stage 1 modules built and tested today, distinguishing them from pending live Sarvam activation and production infrastructure.</a:t>
+              <a:t>Appendix A5 maps built modules, pending live sponsor keys, and planned production infrastructure.</a:t>
             </a:r>
           </a:p>
         </p:txBody>
@@ -727,7 +727,7 @@
           <a:lstStyle/>
           <a:p>
             <a:r>
-              <a:t>Appendix A7 updates the power tile to show both 80/20 allocation (31 control and 124 nudged = 155 total, ~4 waves) and 50/50 even allocation (46 per arm), and labels ~7 percent loan penetration as an assumption.</a:t>
+              <a:t>Appendix A7 presents the exact power curve for pooling 50 shops times one wave, yielding 400 control and 1,600 nudged buyers stratified by shop: 50.3, 68.8, 83.3, 92.5, 97.2, and 99.8 percent power for 4, 5, 6, 7, 8, and 10 point lifts above a 12.5 percent baseline.</a:t>
             </a:r>
           </a:p>
         </p:txBody>
@@ -797,7 +797,7 @@
           <a:lstStyle/>
           <a:p>
             <a:r>
-              <a:t>Appendix A8 explicitly reconciles the Rs 130.50 single-campaign fee on Slide 4 with the Rs 102 per month steady-state promo fee assumption and updates ARR to Paytm's 1.64 crore Q2 FY27 merchant base.</a:t>
+              <a:t>Appendix A8 reconciles the Rs 130.50 single-campaign fee on Slide 4 with the Rs 102 per month steady-state promo fee assumption and updates ARR to Paytm's 1.64 crore Q2 FY27 merchant base.</a:t>
             </a:r>
           </a:p>
         </p:txBody>
@@ -867,7 +867,7 @@
           <a:lstStyle/>
           <a:p>
             <a:r>
-              <a:t>Appendix A9 specifies our exact 80/20 power sample target of about 31 control and 124 nudged buyers across 4 waves, or 46 per arm at an even split.</a:t>
+              <a:t>Appendix A9 states our exact pooled 50-shop stratified pilot design and go/no-go advancement rule: advance only if the lower 95 percent bound of net profit per nudged customer after the 5 percent fee is above zero and the observed lift exceeds the break-even lift.</a:t>
             </a:r>
           </a:p>
         </p:txBody>
@@ -937,7 +937,7 @@
           <a:lstStyle/>
           <a:p>
             <a:r>
-              <a:t>Appendix A10 demonstrates our Task 14 communication layer separating jargon-free merchant scorecards from full statistical audit metrics and grading every claim A, B, or C.</a:t>
+              <a:t>Appendix A10 contrasts our jargon-free merchant scorecard with Technical View and reports honest copy review status across all three languages.</a:t>
             </a:r>
           </a:p>
         </p:txBody>
@@ -1077,7 +1077,7 @@
           <a:lstStyle/>
           <a:p>
             <a:r>
-              <a:t>At 8:30 PM closing time, VyaparVoice delivers a plain-language brief with zero statistical jargon. On our seeded synthetic ledger of 240 payers and 1,613 scans, SQL filters 48 lapsed regulars down to 40 eligible buyers, holding 8 in silent control and issuing Rs 25 passes to all 32 nudged buyers, with an atomic Rs 300 hard stop on actual cashback spend and an upfront warning when cap-overrun risk exceeds 10 percent. Judges can scan the QR code to open our live Render deployment, where each visitor receives an isolated SQLite session.</a:t>
+              <a:t>At 8:30 PM closing time, VyaparVoice delivers a plain-language brief with zero statistical jargon; English copy is author-checked with native review pending, while Kannada and Hindi are marked unreviewed drafts. On our seeded synthetic ledger of 240 payers and 1,613 scans, SQL filters 48 lapsed regulars down to 40 eligible buyers, holding 8 in silent control and issuing Rs 25 passes to all 32 nudged buyers with terms valid while the shop's offer budget lasts, backed by an atomic Rs 300 hard spend stop and an upfront warning when cap-overrun risk exceeds 10 percent.</a:t>
             </a:r>
           </a:p>
         </p:txBody>
@@ -1147,7 +1147,7 @@
           <a:lstStyle/>
           <a:p>
             <a:r>
-              <a:t>Slide 3 separates verified code running in our repository today from pending live sponsor keys and production integrations. Stage 1 added exact Fisher and Wilson tests, unequal-allocation power math, atomic thread-safe spend stopping, banned-jargon copy linting, Evidence Grades A/B/C, visitor session isolation, and a mock-tested keyless Sarvam adapter capped at 30 percent of credits.</a:t>
+              <a:t>Slide 3 separates verified code running in our repository today from pending live sponsor keys and production integrations. Built modules include exact Fisher and Wilson statistics, pooled and unequal-allocation power calculators, atomic thread-safe spend stopping, banned-jargon copy linting, bounded per-visitor SQLite sandboxes, and a mock-tested keyless Sarvam adapter capped at 30 percent of credits.</a:t>
             </a:r>
           </a:p>
         </p:txBody>
@@ -1217,7 +1217,7 @@
           <a:lstStyle/>
           <a:p>
             <a:r>
-              <a:t>Slide 4 presents our Intention-to-Treat holdout and profit waterfall. 12 of 32 nudged buyers return versus 1 of 8 in control, with Fisher exact p equals 0.24, where the simulated 12 returning buyers equals the 12-redemption Rs 300 cap. At our 80/20 allocation of 40 buyers per wave, 80 percent power requires about 31 control and 124 nudged buyers, or 155 total across roughly 4 waves, compared to 46 per arm at a 50/50 split. At a 30 percent store margin, Rs 522 gross profit minus Rs 300 cashback leaves Rs 222 pre-fee, and Rs 91.50 after Paytm's Rs 130.50 5 percent fee levied on all Rs 2,610 redeemed bills including organic returners.</a:t>
+              <a:t>Slide 4 defines Intention-to-Treat: we compare every buyer assigned to receive an offer against every buyer assigned to silent control regardless of whether they redeem or hit the spend stop. In our simulated wave, 12 of 32 nudged buyers return versus 1 of 8 in control, with Fisher exact p equals 0.24, where the simulated 12 returning buyers equals the 12-redemption Rs 300 cap. At a 30 percent store margin, Rs 522 gross profit minus Rs 300 cashback leaves Rs 222 pre-fee, and Rs 91.50 after Paytm's Rs 130.50 5 percent fee levied on all Rs 2,610 redeemed bills including organic returners; post-fee break-even lift is plus 15.3 percentage points.</a:t>
             </a:r>
           </a:p>
         </p:txBody>
@@ -1287,7 +1287,7 @@
           <a:lstStyle/>
           <a:p>
             <a:r>
-              <a:t>Slide 5 updates our scale model to Paytm's Q2 FY27 base of 1.64 crore subscription-paying merchants: 5 percent adoption equals 8.20 lakh shops. SaaS alone at Rs 79 per month yields Rs 77.7 crore ARR; adding steady-state promo fees of Rs 102 per month, corresponding to 0.78 full waves per month or Rs 2,040 in total redeemed bills including organic returners, reaches Rs 178.1 crore ARR with zero lending assumptions; adding credit referrals reaches Rs 253.9 crore ARR. Pooling 4 weekly 80/20 waves per pilot store reaches 160 observations, exceeding the 155 required for 80 percent power.</a:t>
+              <a:t>Slide 5 updates our scale model to Paytm's Q2 FY27 base of 1.64 crore subscription-paying merchants: 5 percent adoption equals 8.20 lakh shops, yielding Rs 77.7 crore ARR on SaaS alone, Rs 178.1 crore adding steady-state promo fees of Rs 102 per month at 0.78 waves per month, and Rs 253.9 crore in our full base case. Rather than claiming a single store runs four full waves in four weeks, which would conflict with our 14-day cooldown and 0.78 waves per month replenishment rate, our pilot pools one wave across 50 shops for roughly 400 control and 1,600 nudged customers stratified by shop, achieving 83.3 percent power at a 6-point lift and 97.2 percent at an 8-point lift.</a:t>
             </a:r>
           </a:p>
         </p:txBody>
@@ -1357,7 +1357,7 @@
           <a:lstStyle/>
           <a:p>
             <a:r>
-              <a:t>Appendix A1 summarizes the updated Q2 FY27 attribution, Intention-to-Treat cap accounting, and Stage 1 verification status.</a:t>
+              <a:t>Appendix A1 summarizes our Q2 FY27 attribution, copy review status, Intention-to-Treat cap accounting, and pooled 50-shop pilot design.</a:t>
             </a:r>
           </a:p>
         </p:txBody>
@@ -1427,7 +1427,7 @@
           <a:lstStyle/>
           <a:p>
             <a:r>
-              <a:t>Appendix A2 cites Paytm's 26 October 2026 Q2 FY27 earnings release directly and tags ~7 percent merchant loan penetration and Rs 90 to 100 monthly Soundbox rental as assumptions.</a:t>
+              <a:t>Appendix A2 cites Paytm's 26 October 2026 Q2 FY27 earnings release for merchant subscriptions, GMV, and operating revenue, while tagging ~7 percent merchant loan penetration and Rs 90 to 100 monthly Soundbox rental as assumptions.</a:t>
             </a:r>
           </a:p>
         </p:txBody>
@@ -1497,7 +1497,7 @@
           <a:lstStyle/>
           <a:p>
             <a:r>
-              <a:t>Appendix A3 maps built Stage 1 modules, simulated MVP flows, and planned Paytm production hooks across Track 1's three pillars.</a:t>
+              <a:t>Appendix A3 maps built modules, simulated MVP flows, and planned Paytm production hooks across Track 1's three pillars.</a:t>
             </a:r>
           </a:p>
         </p:txBody>
@@ -1567,7 +1567,7 @@
           <a:lstStyle/>
           <a:p>
             <a:r>
-              <a:t>Appendix A4 documents our Intention-to-Treat cap-versus-holdout architecture: all 32 nudged buyers receive passes, overrun risk above 10 percent triggers a pre-approval warning and cap suggestion, outcomes are drawn independently before applying the atomic spend stop, and both concurrency and ITT invariance are verified by automated tests.</a:t>
+              <a:t>Appendix A4 details customer pass terms, proactive top-up prompts, decline logging, counter brand risk, and our verified concurrency and ITT invariance tests.</a:t>
             </a:r>
           </a:p>
         </p:txBody>
@@ -4865,7 +4865,7 @@
                 </a:solidFill>
                 <a:latin typeface="Liberation Sans"/>
               </a:rPr>
-              <a:t>Paytm Build for India AI Hackathon (Bengaluru Track 1) | Traced to results/slide_numbers.md (Paytm Q2 FY27)</a:t>
+              <a:t>Paytm Build for India AI Hackathon (Bengaluru Track 1) | Traced to results/slide_numbers.md (Deck v2.1)</a:t>
             </a:r>
           </a:p>
         </p:txBody>
@@ -5500,7 +5500,7 @@
                 </a:solidFill>
                 <a:latin typeface="Liberation Sans"/>
               </a:rPr>
-              <a:t>Component Status: Built in Stage 1 vs Pending vs Production Plan</a:t>
+              <a:t>Component Status: Built vs Pending vs Production Plan</a:t>
             </a:r>
           </a:p>
         </p:txBody>
@@ -5582,7 +5582,7 @@
                 </a:solidFill>
                 <a:latin typeface="Liberation Sans"/>
               </a:rPr>
-              <a:t>Paytm Build for India AI Hackathon (Bengaluru Track 1) | Traced to results/slide_numbers.md (Paytm Q2 FY27)</a:t>
+              <a:t>Paytm Build for India AI Hackathon (Bengaluru Track 1) | Traced to results/slide_numbers.md (Deck v2.1)</a:t>
             </a:r>
           </a:p>
         </p:txBody>
@@ -6610,7 +6610,7 @@
                 </a:solidFill>
                 <a:latin typeface="Liberation Sans"/>
               </a:rPr>
-              <a:t>[BUILT] FastAPI + Per-Visitor Sessions</a:t>
+              <a:t>[BUILT] FastAPI + TTL/LRU/Byte Sessions</a:t>
             </a:r>
           </a:p>
         </p:txBody>
@@ -7083,7 +7083,7 @@
                 </a:solidFill>
                 <a:latin typeface="Liberation Sans"/>
               </a:rPr>
-              <a:t>[BUILT] Preflight + 25-Thread Stress Test</a:t>
+              <a:t>[BUILT] Automated Preflight + Stress Suite</a:t>
             </a:r>
           </a:p>
         </p:txBody>
@@ -7484,7 +7484,7 @@
                 </a:solidFill>
                 <a:latin typeface="Liberation Sans"/>
               </a:rPr>
-              <a:t>Paytm Build for India AI Hackathon (Bengaluru Track 1) | Traced to results/slide_numbers.md (Paytm Q2 FY27)</a:t>
+              <a:t>Paytm Build for India AI Hackathon (Bengaluru Track 1) | Traced to results/slide_numbers.md (Deck v2.1)</a:t>
             </a:r>
           </a:p>
         </p:txBody>
@@ -8129,7 +8129,7 @@
                         </a:defRPr>
                       </a:pPr>
                       <a:r>
-                        <a:t>80/20 ITT holdout + Wilson CIs + net profit ROI</a:t>
+                        <a:t>80/20 ITT holdout + 50-shop stratified pilot</a:t>
                       </a:r>
                     </a:p>
                   </a:txBody>
@@ -8222,7 +8222,7 @@
         <p:spPr>
           <a:xfrm>
             <a:off x="502920" y="219456"/>
-            <a:ext cx="3497580" cy="292608"/>
+            <a:ext cx="3584448" cy="292608"/>
           </a:xfrm>
           <a:prstGeom prst="roundRect">
             <a:avLst>
@@ -8269,7 +8269,7 @@
         <p:spPr>
           <a:xfrm>
             <a:off x="548640" y="246888"/>
-            <a:ext cx="3406140" cy="237744"/>
+            <a:ext cx="3493008" cy="237744"/>
           </a:xfrm>
           <a:prstGeom prst="rect">
             <a:avLst/>
@@ -8294,7 +8294,7 @@
                 </a:solidFill>
                 <a:latin typeface="Liberation Sans"/>
               </a:rPr>
-              <a:t>APPENDIX A7 : PILOT TARGETS &amp; POWER</a:t>
+              <a:t>APPENDIX A7 : POOLED POWER &amp; TARGETS</a:t>
             </a:r>
           </a:p>
         </p:txBody>
@@ -8372,7 +8372,7 @@
                 </a:solidFill>
                 <a:latin typeface="Liberation Sans"/>
               </a:rPr>
-              <a:t>Hypothesized Pilot Targets vs Simulated ITT Metrics</a:t>
+              <a:t>50-Shop Stratified Power (400C + 1,600T) &amp; Pilot Targets</a:t>
             </a:r>
           </a:p>
         </p:txBody>
@@ -8454,7 +8454,7 @@
                 </a:solidFill>
                 <a:latin typeface="Liberation Sans"/>
               </a:rPr>
-              <a:t>Paytm Build for India AI Hackathon (Bengaluru Track 1) | Traced to results/slide_numbers.md (Paytm Q2 FY27)</a:t>
+              <a:t>Paytm Build for India AI Hackathon (Bengaluru Track 1) | Traced to results/slide_numbers.md (Deck v2.1)</a:t>
             </a:r>
           </a:p>
         </p:txBody>
@@ -8507,7 +8507,7 @@
         <p:spPr>
           <a:xfrm>
             <a:off x="502920" y="1298448"/>
-            <a:ext cx="5943600" cy="2377440"/>
+            <a:ext cx="5943600" cy="2487168"/>
           </a:xfrm>
           <a:prstGeom prst="roundRect">
             <a:avLst>
@@ -8553,8 +8553,8 @@
         </p:nvSpPr>
         <p:spPr>
           <a:xfrm>
-            <a:off x="685800" y="1408176"/>
-            <a:ext cx="5577840" cy="274320"/>
+            <a:off x="685800" y="1389888"/>
+            <a:ext cx="5577840" cy="256032"/>
           </a:xfrm>
           <a:prstGeom prst="rect">
             <a:avLst/>
@@ -8573,13 +8573,13 @@
               </a:spcAft>
             </a:pPr>
             <a:r>
-              <a:rPr sz="1200" b="1" i="0">
-                <a:solidFill>
-                  <a:srgbClr val="059669"/>
-                </a:solidFill>
-                <a:latin typeface="Liberation Sans"/>
-              </a:rPr>
-              <a:t>MERCHANT METRICS (SIMULATED MVP &amp; PILOT TARGETS)</a:t>
+              <a:rPr sz="1150" b="1" i="0">
+                <a:solidFill>
+                  <a:srgbClr val="002970"/>
+                </a:solidFill>
+                <a:latin typeface="Liberation Sans"/>
+              </a:rPr>
+              <a:t>POOLED 50-SHOP X 1-WAVE POWER (12.5% BASELINE, ALPHA=0.05)</a:t>
             </a:r>
           </a:p>
         </p:txBody>
@@ -8592,8 +8592,8 @@
         </p:nvSpPr>
         <p:spPr>
           <a:xfrm>
-            <a:off x="658368" y="1719072"/>
-            <a:ext cx="5623560" cy="1874519"/>
+            <a:off x="658368" y="1682496"/>
+            <a:ext cx="5623560" cy="2029968"/>
           </a:xfrm>
           <a:prstGeom prst="rect">
             <a:avLst/>
@@ -8608,79 +8608,79 @@
           <a:p>
             <a:pPr marL="210000" indent="-210000">
               <a:spcAft>
-                <a:spcPts val="600"/>
+                <a:spcPts val="500"/>
               </a:spcAft>
               <a:buChar char="•"/>
             </a:pPr>
             <a:r>
-              <a:rPr sz="1150" b="1">
+              <a:rPr sz="1100" b="1">
                 <a:solidFill>
                   <a:srgbClr val="002970"/>
                 </a:solidFill>
                 <a:latin typeface="Liberation Sans"/>
               </a:rPr>
-              <a:t>Simulated Profit ROI: </a:t>
-            </a:r>
-            <a:r>
-              <a:rPr sz="1150" b="0">
+              <a:t>Why Pool Stores: </a:t>
+            </a:r>
+            <a:r>
+              <a:rPr sz="1100" b="0">
                 <a:solidFill>
                   <a:srgbClr val="0F172A"/>
                 </a:solidFill>
                 <a:latin typeface="Liberation Sans"/>
               </a:rPr>
-              <a:t>+Rs 222 pre-fee (+74%) / +Rs 91.50 post-fee at 30% margin (simulated 12 = Rs 300 cap).</a:t>
+              <a:t>50 shops x 1 wave (~400C + ~1,600T, stratified by shop); avoids claiming 1 shop runs 4 waves in 4w under a 14d cooldown (~0.78 waves/mo).</a:t>
             </a:r>
           </a:p>
           <a:p>
             <a:pPr marL="210000" indent="-210000">
               <a:spcAft>
-                <a:spcPts val="600"/>
+                <a:spcPts val="500"/>
               </a:spcAft>
               <a:buChar char="•"/>
             </a:pPr>
             <a:r>
-              <a:rPr sz="1150" b="1">
+              <a:rPr sz="1100" b="1">
                 <a:solidFill>
                   <a:srgbClr val="002970"/>
                 </a:solidFill>
                 <a:latin typeface="Liberation Sans"/>
               </a:rPr>
-              <a:t>Repeat Visit Target: </a:t>
-            </a:r>
-            <a:r>
-              <a:rPr sz="1150" b="0">
+              <a:t>Exact Power Curve: </a:t>
+            </a:r>
+            <a:r>
+              <a:rPr sz="1100" b="0">
                 <a:solidFill>
                   <a:srgbClr val="0F172A"/>
                 </a:solidFill>
                 <a:latin typeface="Liberation Sans"/>
               </a:rPr>
-              <a:t>+14% to +22% monthly repeat visits (PILOT TARGET - unvalidated).</a:t>
+              <a:t>+4 pp: 50.3% | +5 pp: 68.8% | +6 pp: 83.3% | +7 pp: 92.5% | +8 pp: 97.2% | +10 pp: 99.8%.</a:t>
             </a:r>
           </a:p>
           <a:p>
             <a:pPr marL="210000" indent="-210000">
               <a:spcAft>
-                <a:spcPts val="600"/>
+                <a:spcPts val="500"/>
               </a:spcAft>
               <a:buChar char="•"/>
             </a:pPr>
             <a:r>
-              <a:rPr sz="1150" b="1">
+              <a:rPr sz="1100" b="1">
                 <a:solidFill>
                   <a:srgbClr val="002970"/>
                 </a:solidFill>
                 <a:latin typeface="Liberation Sans"/>
               </a:rPr>
-              <a:t>Waste Reduction Target: </a:t>
-            </a:r>
-            <a:r>
-              <a:rPr sz="1150" b="0">
+              <a:t>Break-Even Lift: </a:t>
+            </a:r>
+            <a:r>
+              <a:rPr sz="1100" b="0">
                 <a:solidFill>
                   <a:srgbClr val="0F172A"/>
                 </a:solidFill>
                 <a:latin typeface="Liberation Sans"/>
               </a:rPr>
-              <a:t>-18% afternoon perishable loss (PILOT TARGET - unvalidated).</a:t>
+              <a:t>+7.8 pp pre-fee (20.3%) and +15.3 pp post-5%-fee (27.8% at 30% shop margin; &gt;99.9% power).</a:t>
             </a:r>
           </a:p>
         </p:txBody>
@@ -8693,8 +8693,8 @@
         </p:nvSpPr>
         <p:spPr>
           <a:xfrm>
-            <a:off x="502920" y="3840480"/>
-            <a:ext cx="5943600" cy="2423160"/>
+            <a:off x="502920" y="3913632"/>
+            <a:ext cx="5943600" cy="2350008"/>
           </a:xfrm>
           <a:prstGeom prst="roundRect">
             <a:avLst>
@@ -8740,8 +8740,8 @@
         </p:nvSpPr>
         <p:spPr>
           <a:xfrm>
-            <a:off x="685800" y="3950208"/>
-            <a:ext cx="5577840" cy="274320"/>
+            <a:off x="685800" y="4005072"/>
+            <a:ext cx="5577840" cy="256032"/>
           </a:xfrm>
           <a:prstGeom prst="rect">
             <a:avLst/>
@@ -8760,13 +8760,13 @@
               </a:spcAft>
             </a:pPr>
             <a:r>
-              <a:rPr sz="1200" b="1" i="0">
-                <a:solidFill>
-                  <a:srgbClr val="002970"/>
-                </a:solidFill>
-                <a:latin typeface="Liberation Sans"/>
-              </a:rPr>
-              <a:t>PAYTM ECOSYSTEM HYPOTHESES (PILOT TARGETS)</a:t>
+              <a:rPr sz="1150" b="1" i="0">
+                <a:solidFill>
+                  <a:srgbClr val="059669"/>
+                </a:solidFill>
+                <a:latin typeface="Liberation Sans"/>
+              </a:rPr>
+              <a:t>ECOSYSTEM HYPOTHESES (UNVALIDATED PILOT TARGETS)</a:t>
             </a:r>
           </a:p>
         </p:txBody>
@@ -8779,7 +8779,7 @@
         </p:nvSpPr>
         <p:spPr>
           <a:xfrm>
-            <a:off x="658368" y="4261104"/>
+            <a:off x="658368" y="4297680"/>
             <a:ext cx="5623560" cy="1874519"/>
           </a:xfrm>
           <a:prstGeom prst="rect">
@@ -8795,64 +8795,64 @@
           <a:p>
             <a:pPr marL="210000" indent="-210000">
               <a:spcAft>
-                <a:spcPts val="600"/>
+                <a:spcPts val="500"/>
               </a:spcAft>
               <a:buChar char="•"/>
             </a:pPr>
             <a:r>
-              <a:rPr sz="1150" b="1">
+              <a:rPr sz="1100" b="1">
                 <a:solidFill>
                   <a:srgbClr val="002970"/>
                 </a:solidFill>
                 <a:latin typeface="Liberation Sans"/>
               </a:rPr>
-              <a:t>Device Retention: </a:t>
-            </a:r>
-            <a:r>
-              <a:rPr sz="1150" b="0">
+              <a:t>Repeat &amp; Waste Targets: </a:t>
+            </a:r>
+            <a:r>
+              <a:rPr sz="1100" b="0">
                 <a:solidFill>
                   <a:srgbClr val="0F172A"/>
                 </a:solidFill>
                 <a:latin typeface="Liberation Sans"/>
               </a:rPr>
-              <a:t>-35% Soundbox churn reduction (PILOT TARGET - unvalidated).</a:t>
+              <a:t>+14% to +22% repeat visits; -18% afternoon perishable loss (PILOT TARGETS).</a:t>
             </a:r>
           </a:p>
           <a:p>
             <a:pPr marL="210000" indent="-210000">
               <a:spcAft>
-                <a:spcPts val="600"/>
+                <a:spcPts val="500"/>
               </a:spcAft>
               <a:buChar char="•"/>
             </a:pPr>
             <a:r>
-              <a:rPr sz="1150" b="1">
+              <a:rPr sz="1100" b="1">
                 <a:solidFill>
                   <a:srgbClr val="002970"/>
                 </a:solidFill>
                 <a:latin typeface="Liberation Sans"/>
               </a:rPr>
-              <a:t>Store QR Share: </a:t>
-            </a:r>
-            <a:r>
-              <a:rPr sz="1150" b="0">
+              <a:t>Device &amp; QR Share: </a:t>
+            </a:r>
+            <a:r>
+              <a:rPr sz="1100" b="0">
                 <a:solidFill>
                   <a:srgbClr val="0F172A"/>
                 </a:solidFill>
                 <a:latin typeface="Liberation Sans"/>
               </a:rPr>
-              <a:t>+12% to +15% store Paytm QR GMV lift (PILOT TARGET - unvalidated).</a:t>
+              <a:t>-35% Soundbox churn; +12% to +15% store Paytm QR GMV lift (PILOT TARGETS).</a:t>
             </a:r>
           </a:p>
           <a:p>
             <a:pPr marL="210000" indent="-210000">
               <a:spcAft>
-                <a:spcPts val="600"/>
+                <a:spcPts val="500"/>
               </a:spcAft>
               <a:buChar char="•"/>
             </a:pPr>
             <a:r>
-              <a:rPr sz="1150" b="1">
+              <a:rPr sz="1100" b="1">
                 <a:solidFill>
                   <a:srgbClr val="002970"/>
                 </a:solidFill>
@@ -8861,7 +8861,7 @@
               <a:t>Credit Funnel: </a:t>
             </a:r>
             <a:r>
-              <a:rPr sz="1150" b="0">
+              <a:rPr sz="1100" b="0">
                 <a:solidFill>
                   <a:srgbClr val="0F172A"/>
                 </a:solidFill>
@@ -8921,7 +8921,7 @@
       </p:sp>
       <p:pic>
         <p:nvPicPr>
-          <p:cNvPr id="17" name="Picture 16" descr="c2_honest_holdout.png"/>
+          <p:cNvPr id="17" name="Picture 16" descr="c5_pooled_power.png"/>
           <p:cNvPicPr>
             <a:picLocks noChangeAspect="1"/>
           </p:cNvPicPr>
@@ -8935,8 +8935,8 @@
         </p:blipFill>
         <p:spPr>
           <a:xfrm>
-            <a:off x="6949440" y="1353312"/>
-            <a:ext cx="4407408" cy="2952963"/>
+            <a:off x="6876288" y="1353312"/>
+            <a:ext cx="4553712" cy="3050987"/>
           </a:xfrm>
           <a:prstGeom prst="rect">
             <a:avLst/>
@@ -9024,7 +9024,7 @@
                 </a:solidFill>
                 <a:latin typeface="Liberation Sans"/>
               </a:rPr>
-              <a:t>1.74x</a:t>
+              <a:t>83.3%</a:t>
             </a:r>
           </a:p>
         </p:txBody>
@@ -9063,7 +9063,7 @@
                 </a:solidFill>
                 <a:latin typeface="Liberation Sans"/>
               </a:rPr>
-              <a:t>Gross Profit / Promo</a:t>
+              <a:t>Power at +6 pp Lift</a:t>
             </a:r>
           </a:p>
           <a:p>
@@ -9079,7 +9079,7 @@
                 </a:solidFill>
                 <a:latin typeface="Liberation Sans"/>
               </a:rPr>
-              <a:t>(30% Margin Sim.)</a:t>
+              <a:t>(400C + 1,600T)</a:t>
             </a:r>
           </a:p>
         </p:txBody>
@@ -9165,7 +9165,7 @@
                 </a:solidFill>
                 <a:latin typeface="Liberation Sans"/>
               </a:rPr>
-              <a:t>31C + 124T</a:t>
+              <a:t>+15.3 pp</a:t>
             </a:r>
           </a:p>
         </p:txBody>
@@ -9204,7 +9204,7 @@
                 </a:solidFill>
                 <a:latin typeface="Liberation Sans"/>
               </a:rPr>
-              <a:t>80/20 Power (155, ~4w)</a:t>
+              <a:t>Post-Fee Break-Even</a:t>
             </a:r>
           </a:p>
           <a:p>
@@ -9220,7 +9220,7 @@
                 </a:solidFill>
                 <a:latin typeface="Liberation Sans"/>
               </a:rPr>
-              <a:t>46/arm at 50/50</a:t>
+              <a:t>(+7.8 pp Pre-Fee)</a:t>
             </a:r>
           </a:p>
         </p:txBody>
@@ -9676,7 +9676,7 @@
                 </a:solidFill>
                 <a:latin typeface="Liberation Sans"/>
               </a:rPr>
-              <a:t>Paytm Build for India AI Hackathon (Bengaluru Track 1) | Traced to results/slide_numbers.md (Paytm Q2 FY27)</a:t>
+              <a:t>Paytm Build for India AI Hackathon (Bengaluru Track 1) | Traced to results/slide_numbers.md (Deck v2.1)</a:t>
             </a:r>
           </a:p>
         </p:txBody>
@@ -9791,12 +9791,12 @@
           <a:p>
             <a:pPr marL="210000" indent="-210000">
               <a:spcAft>
-                <a:spcPts val="800"/>
+                <a:spcPts val="900"/>
               </a:spcAft>
               <a:buChar char="•"/>
             </a:pPr>
             <a:r>
-              <a:rPr sz="1100" b="1">
+              <a:rPr sz="1120" b="1">
                 <a:solidFill>
                   <a:srgbClr val="002970"/>
                 </a:solidFill>
@@ -9805,7 +9805,7 @@
               <a:t>Stream 1 (SaaS - Rs 79/mo): </a:t>
             </a:r>
             <a:r>
-              <a:rPr sz="1100" b="0">
+              <a:rPr sz="1120" b="0">
                 <a:solidFill>
                   <a:srgbClr val="0F172A"/>
                 </a:solidFill>
@@ -9817,12 +9817,12 @@
           <a:p>
             <a:pPr marL="210000" indent="-210000">
               <a:spcAft>
-                <a:spcPts val="800"/>
+                <a:spcPts val="900"/>
               </a:spcAft>
               <a:buChar char="•"/>
             </a:pPr>
             <a:r>
-              <a:rPr sz="1100" b="1">
+              <a:rPr sz="1120" b="1">
                 <a:solidFill>
                   <a:srgbClr val="002970"/>
                 </a:solidFill>
@@ -9831,7 +9831,7 @@
               <a:t>Stream 2 (Promo Fee - Rs 102/mo): </a:t>
             </a:r>
             <a:r>
-              <a:rPr sz="1100" b="0">
+              <a:rPr sz="1120" b="0">
                 <a:solidFill>
                   <a:srgbClr val="0F172A"/>
                 </a:solidFill>
@@ -9843,12 +9843,12 @@
           <a:p>
             <a:pPr marL="210000" indent="-210000">
               <a:spcAft>
-                <a:spcPts val="800"/>
+                <a:spcPts val="900"/>
               </a:spcAft>
               <a:buChar char="•"/>
             </a:pPr>
             <a:r>
-              <a:rPr sz="1100" b="1">
+              <a:rPr sz="1120" b="1">
                 <a:solidFill>
                   <a:srgbClr val="002970"/>
                 </a:solidFill>
@@ -9857,7 +9857,7 @@
               <a:t>Stream 3 (Credit - Rs 77/mo): </a:t>
             </a:r>
             <a:r>
-              <a:rPr sz="1100" b="0">
+              <a:rPr sz="1120" b="0">
                 <a:solidFill>
                   <a:srgbClr val="0F172A"/>
                 </a:solidFill>
@@ -9869,12 +9869,12 @@
           <a:p>
             <a:pPr marL="210000" indent="-210000">
               <a:spcAft>
-                <a:spcPts val="800"/>
+                <a:spcPts val="900"/>
               </a:spcAft>
               <a:buChar char="•"/>
             </a:pPr>
             <a:r>
-              <a:rPr sz="1100" b="1">
+              <a:rPr sz="1120" b="1">
                 <a:solidFill>
                   <a:srgbClr val="002970"/>
                 </a:solidFill>
@@ -9883,7 +9883,7 @@
               <a:t>Cached COGS (Rs 48.00/mo): </a:t>
             </a:r>
             <a:r>
-              <a:rPr sz="1100" b="0">
+              <a:rPr sz="1120" b="0">
                 <a:solidFill>
                   <a:srgbClr val="0F172A"/>
                 </a:solidFill>
@@ -9895,12 +9895,12 @@
           <a:p>
             <a:pPr marL="210000" indent="-210000">
               <a:spcAft>
-                <a:spcPts val="800"/>
+                <a:spcPts val="900"/>
               </a:spcAft>
               <a:buChar char="•"/>
             </a:pPr>
             <a:r>
-              <a:rPr sz="1100" b="1">
+              <a:rPr sz="1120" b="1">
                 <a:solidFill>
                   <a:srgbClr val="002970"/>
                 </a:solidFill>
@@ -9909,7 +9909,7 @@
               <a:t>Uncached COGS (Rs 71.80/mo): </a:t>
             </a:r>
             <a:r>
-              <a:rPr sz="1100" b="0">
+              <a:rPr sz="1120" b="0">
                 <a:solidFill>
                   <a:srgbClr val="0F172A"/>
                 </a:solidFill>
@@ -10228,7 +10228,7 @@
                 </a:solidFill>
                 <a:latin typeface="Liberation Sans"/>
               </a:rPr>
-              <a:t>APPENDIX A9 : VALIDATION &amp; ROLLOUT ROADMAP</a:t>
+              <a:t>APPENDIX A9 : VALIDATION &amp; GO / NO-GO DECISION RULE</a:t>
             </a:r>
           </a:p>
         </p:txBody>
@@ -10267,7 +10267,7 @@
                 </a:solidFill>
                 <a:latin typeface="Liberation Sans"/>
               </a:rPr>
-              <a:t>From Stage-1 Verified MVP to Powered 50-Store Bengaluru Pilot</a:t>
+              <a:t>From Verified Synthetic MVP to Pooled 50-Shop Stratified Pilot</a:t>
             </a:r>
           </a:p>
         </p:txBody>
@@ -10281,7 +10281,7 @@
         <p:spPr>
           <a:xfrm>
             <a:off x="594360" y="1508760"/>
-            <a:ext cx="3520440" cy="3520440"/>
+            <a:ext cx="3520440" cy="3547872"/>
           </a:xfrm>
           <a:prstGeom prst="roundRect">
             <a:avLst>
@@ -10353,7 +10353,7 @@
                 </a:solidFill>
                 <a:latin typeface="Liberation Sans"/>
               </a:rPr>
-              <a:t>STAGE A : BUILT &amp; TESTED (STAGE 1)</a:t>
+              <a:t>STAGE A : BUILT &amp; VERIFIED</a:t>
             </a:r>
           </a:p>
         </p:txBody>
@@ -10386,7 +10386,7 @@
               </a:spcAft>
             </a:pPr>
             <a:r>
-              <a:rPr sz="1420" b="1" i="0">
+              <a:rPr sz="1400" b="1" i="0">
                 <a:solidFill>
                   <a:srgbClr val="FFFFFF"/>
                 </a:solidFill>
@@ -10405,8 +10405,8 @@
         </p:nvSpPr>
         <p:spPr>
           <a:xfrm>
-            <a:off x="722376" y="2359152"/>
-            <a:ext cx="3255264" cy="2514600"/>
+            <a:off x="722376" y="2340864"/>
+            <a:ext cx="3255264" cy="2578608"/>
           </a:xfrm>
           <a:prstGeom prst="rect">
             <a:avLst/>
@@ -10421,29 +10421,29 @@
           <a:p>
             <a:pPr marL="210000" indent="-210000">
               <a:spcAft>
-                <a:spcPts val="1000"/>
+                <a:spcPts val="900"/>
               </a:spcAft>
               <a:buChar char="•"/>
             </a:pPr>
             <a:r>
-              <a:rPr sz="1120">
+              <a:rPr sz="1080">
                 <a:solidFill>
                   <a:srgbClr val="E2E8F0"/>
                 </a:solidFill>
                 <a:latin typeface="Liberation Sans"/>
               </a:rPr>
-              <a:t>FastAPI + per-visitor SQLite sandboxes (240 payers, 1,613 scans)</a:t>
+              <a:t>FastAPI + TTL/LRU/byte-bounded SQLite sessions (204 KB/visitor)</a:t>
             </a:r>
           </a:p>
           <a:p>
             <a:pPr marL="210000" indent="-210000">
               <a:spcAft>
-                <a:spcPts val="1000"/>
+                <a:spcPts val="900"/>
               </a:spcAft>
               <a:buChar char="•"/>
             </a:pPr>
             <a:r>
-              <a:rPr sz="1120">
+              <a:rPr sz="1080">
                 <a:solidFill>
                   <a:srgbClr val="E2E8F0"/>
                 </a:solidFill>
@@ -10455,12 +10455,12 @@
           <a:p>
             <a:pPr marL="210000" indent="-210000">
               <a:spcAft>
-                <a:spcPts val="1000"/>
+                <a:spcPts val="900"/>
               </a:spcAft>
               <a:buChar char="•"/>
             </a:pPr>
             <a:r>
-              <a:rPr sz="1120">
+              <a:rPr sz="1080">
                 <a:solidFill>
                   <a:srgbClr val="E2E8F0"/>
                 </a:solidFill>
@@ -10480,7 +10480,7 @@
         <p:spPr>
           <a:xfrm>
             <a:off x="4343400" y="1508760"/>
-            <a:ext cx="3520440" cy="3520440"/>
+            <a:ext cx="3520440" cy="3547872"/>
           </a:xfrm>
           <a:prstGeom prst="roundRect">
             <a:avLst>
@@ -10552,7 +10552,7 @@
                 </a:solidFill>
                 <a:latin typeface="Liberation Sans"/>
               </a:rPr>
-              <a:t>STAGE B : DAYS 1 TO 30 PILOT</a:t>
+              <a:t>STAGE B : POOLED 50-SHOP PILOT</a:t>
             </a:r>
           </a:p>
         </p:txBody>
@@ -10585,13 +10585,13 @@
               </a:spcAft>
             </a:pPr>
             <a:r>
-              <a:rPr sz="1420" b="1" i="0">
+              <a:rPr sz="1400" b="1" i="0">
                 <a:solidFill>
                   <a:srgbClr val="FFFFFF"/>
                 </a:solidFill>
                 <a:latin typeface="Liberation Sans"/>
               </a:rPr>
-              <a:t>Bengaluru 50-Store Validation</a:t>
+              <a:t>Stratified Single-Wave Validation</a:t>
             </a:r>
           </a:p>
         </p:txBody>
@@ -10604,8 +10604,8 @@
         </p:nvSpPr>
         <p:spPr>
           <a:xfrm>
-            <a:off x="4471416" y="2359152"/>
-            <a:ext cx="3255264" cy="2514600"/>
+            <a:off x="4471416" y="2340864"/>
+            <a:ext cx="3255264" cy="2578608"/>
           </a:xfrm>
           <a:prstGeom prst="rect">
             <a:avLst/>
@@ -10620,52 +10620,52 @@
           <a:p>
             <a:pPr marL="210000" indent="-210000">
               <a:spcAft>
-                <a:spcPts val="1000"/>
+                <a:spcPts val="900"/>
               </a:spcAft>
               <a:buChar char="•"/>
             </a:pPr>
             <a:r>
-              <a:rPr sz="1120">
+              <a:rPr sz="1080">
                 <a:solidFill>
                   <a:srgbClr val="E2E8F0"/>
                 </a:solidFill>
                 <a:latin typeface="Liberation Sans"/>
               </a:rPr>
-              <a:t>Complete 3-merchant native Kannada &amp; Hindi teach-back review</a:t>
+              <a:t>3-merchant counter teach-back across EN (author-checked), KN &amp; HI (draft)</a:t>
             </a:r>
           </a:p>
           <a:p>
             <a:pPr marL="210000" indent="-210000">
               <a:spcAft>
-                <a:spcPts val="1000"/>
+                <a:spcPts val="900"/>
               </a:spcAft>
               <a:buChar char="•"/>
             </a:pPr>
             <a:r>
-              <a:rPr sz="1120">
+              <a:rPr sz="1080">
                 <a:solidFill>
                   <a:srgbClr val="E2E8F0"/>
                 </a:solidFill>
                 <a:latin typeface="Liberation Sans"/>
               </a:rPr>
-              <a:t>Pool ~4 weekly 80/20 waves (~31C + ~124T = 155; or 46/arm at 50/50)</a:t>
+              <a:t>50 shops x 1 wave (~400C + ~1,600T, stratified by shop; 83.3% power at +6 pp)</a:t>
             </a:r>
           </a:p>
           <a:p>
             <a:pPr marL="210000" indent="-210000">
               <a:spcAft>
-                <a:spcPts val="1000"/>
+                <a:spcPts val="900"/>
               </a:spcAft>
               <a:buChar char="•"/>
             </a:pPr>
             <a:r>
-              <a:rPr sz="1120">
+              <a:rPr sz="1080">
                 <a:solidFill>
                   <a:srgbClr val="E2E8F0"/>
                 </a:solidFill>
                 <a:latin typeface="Liberation Sans"/>
               </a:rPr>
-              <a:t>Advance only if net merchant profit post-fee &amp; refusals has p &lt; 0.05</a:t>
+              <a:t>Advance only if lower 95% bound of post-5%-fee net profit/nudged &gt; 0 AND lift &gt; break-even (+15.3 pp)</a:t>
             </a:r>
           </a:p>
         </p:txBody>
@@ -10679,7 +10679,7 @@
         <p:spPr>
           <a:xfrm>
             <a:off x="8092440" y="1508760"/>
-            <a:ext cx="3520440" cy="3520440"/>
+            <a:ext cx="3520440" cy="3547872"/>
           </a:xfrm>
           <a:prstGeom prst="roundRect">
             <a:avLst>
@@ -10784,7 +10784,7 @@
               </a:spcAft>
             </a:pPr>
             <a:r>
-              <a:rPr sz="1420" b="1" i="0">
+              <a:rPr sz="1400" b="1" i="0">
                 <a:solidFill>
                   <a:srgbClr val="FFFFFF"/>
                 </a:solidFill>
@@ -10803,8 +10803,8 @@
         </p:nvSpPr>
         <p:spPr>
           <a:xfrm>
-            <a:off x="8220456" y="2359152"/>
-            <a:ext cx="3255264" cy="2514600"/>
+            <a:off x="8220456" y="2340864"/>
+            <a:ext cx="3255264" cy="2578608"/>
           </a:xfrm>
           <a:prstGeom prst="rect">
             <a:avLst/>
@@ -10819,12 +10819,12 @@
           <a:p>
             <a:pPr marL="210000" indent="-210000">
               <a:spcAft>
-                <a:spcPts val="1000"/>
+                <a:spcPts val="900"/>
               </a:spcAft>
               <a:buChar char="•"/>
             </a:pPr>
             <a:r>
-              <a:rPr sz="1120">
+              <a:rPr sz="1080">
                 <a:solidFill>
                   <a:srgbClr val="E2E8F0"/>
                 </a:solidFill>
@@ -10836,29 +10836,29 @@
           <a:p>
             <a:pPr marL="210000" indent="-210000">
               <a:spcAft>
-                <a:spcPts val="1000"/>
+                <a:spcPts val="900"/>
               </a:spcAft>
               <a:buChar char="•"/>
             </a:pPr>
             <a:r>
-              <a:rPr sz="1120">
+              <a:rPr sz="1080">
                 <a:solidFill>
                   <a:srgbClr val="E2E8F0"/>
                 </a:solidFill>
                 <a:latin typeface="Liberation Sans"/>
               </a:rPr>
-              <a:t>Self-host compact intent models; keep &gt;=88% audio phrase caching</a:t>
+              <a:t>Enforce live 80%-cap merchant top-up prompt to protect counter goodwill</a:t>
             </a:r>
           </a:p>
           <a:p>
             <a:pPr marL="210000" indent="-210000">
               <a:spcAft>
-                <a:spcPts val="1000"/>
+                <a:spcPts val="900"/>
               </a:spcAft>
               <a:buChar char="•"/>
             </a:pPr>
             <a:r>
-              <a:rPr sz="1120">
+              <a:rPr sz="1080">
                 <a:solidFill>
                   <a:srgbClr val="E2E8F0"/>
                 </a:solidFill>
@@ -10925,7 +10925,7 @@
         <p:spPr>
           <a:xfrm>
             <a:off x="822960" y="5413248"/>
-            <a:ext cx="7132320" cy="329184"/>
+            <a:ext cx="8686800" cy="329184"/>
           </a:xfrm>
           <a:prstGeom prst="rect">
             <a:avLst/>
@@ -10983,13 +10983,13 @@
               </a:spcAft>
             </a:pPr>
             <a:r>
-              <a:rPr sz="1150" b="0" i="0">
+              <a:rPr sz="1080" b="0" i="0">
                 <a:solidFill>
                   <a:srgbClr val="00BAF2"/>
                 </a:solidFill>
                 <a:latin typeface="Liberation Sans"/>
               </a:rPr>
-              <a:t>Appendix A9 (Slide 14 / 16) | Live Demo: https://paytmai-vyaparvoice.onrender.com</a:t>
+              <a:t>Appendix A9 (Slide 14 / 16) | Go/No-Go: Lower 95% CI of Post-5%-Fee Net Profit/Nudged &gt; Rs 0 AND Observed Lift &gt; Break-Even Lift</a:t>
             </a:r>
           </a:p>
         </p:txBody>
@@ -11222,7 +11222,7 @@
                 </a:solidFill>
                 <a:latin typeface="Liberation Sans"/>
               </a:rPr>
-              <a:t>Merchant Plain-Language View vs Technical Audit View (Task 14)</a:t>
+              <a:t>Merchant Plain-Language View vs Technical Audit View</a:t>
             </a:r>
           </a:p>
         </p:txBody>
@@ -11304,7 +11304,7 @@
                 </a:solidFill>
                 <a:latin typeface="Liberation Sans"/>
               </a:rPr>
-              <a:t>Paytm Build for India AI Hackathon (Bengaluru Track 1) | Traced to results/slide_numbers.md (Paytm Q2 FY27)</a:t>
+              <a:t>Paytm Build for India AI Hackathon (Bengaluru Track 1) | Traced to results/slide_numbers.md (Deck v2.1)</a:t>
             </a:r>
           </a:p>
         </p:txBody>
@@ -11463,7 +11463,7 @@
               <a:buChar char="•"/>
             </a:pPr>
             <a:r>
-              <a:rPr sz="1150" b="1">
+              <a:rPr sz="1140" b="1">
                 <a:solidFill>
                   <a:srgbClr val="002970"/>
                 </a:solidFill>
@@ -11472,13 +11472,13 @@
               <a:t>Plain Outcome Copy: </a:t>
             </a:r>
             <a:r>
-              <a:rPr sz="1150" b="0">
+              <a:rPr sz="1140" b="0">
                 <a:solidFill>
                   <a:srgbClr val="0F172A"/>
                 </a:solidFill>
                 <a:latin typeface="Liberation Sans"/>
               </a:rPr>
-              <a:t>Early check (run ~4 weekly waves to be sure): 12 of 32 customers with an offer came back vs 1 of 8 without.</a:t>
+              <a:t>Early check on one store wave (pool multiple shops to be sure): 12 of 32 with offer came back vs 1 of 8 without.</a:t>
             </a:r>
           </a:p>
           <a:p>
@@ -11489,7 +11489,7 @@
               <a:buChar char="•"/>
             </a:pPr>
             <a:r>
-              <a:rPr sz="1150" b="1">
+              <a:rPr sz="1140" b="1">
                 <a:solidFill>
                   <a:srgbClr val="002970"/>
                 </a:solidFill>
@@ -11498,7 +11498,7 @@
               <a:t>Clear Spend Stop: </a:t>
             </a:r>
             <a:r>
-              <a:rPr sz="1150" b="0">
+              <a:rPr sz="1140" b="0">
                 <a:solidFill>
                   <a:srgbClr val="0F172A"/>
                 </a:solidFill>
@@ -11515,7 +11515,7 @@
               <a:buChar char="•"/>
             </a:pPr>
             <a:r>
-              <a:rPr sz="1150" b="1">
+              <a:rPr sz="1140" b="1">
                 <a:solidFill>
                   <a:srgbClr val="002970"/>
                 </a:solidFill>
@@ -11524,7 +11524,7 @@
               <a:t>Estimated Shop Profit: </a:t>
             </a:r>
             <a:r>
-              <a:rPr sz="1150" b="0">
+              <a:rPr sz="1140" b="0">
                 <a:solidFill>
                   <a:srgbClr val="0F172A"/>
                 </a:solidFill>
@@ -11541,22 +11541,22 @@
               <a:buChar char="•"/>
             </a:pPr>
             <a:r>
-              <a:rPr sz="1150" b="1">
+              <a:rPr sz="1140" b="1">
                 <a:solidFill>
                   <a:srgbClr val="002970"/>
                 </a:solidFill>
                 <a:latin typeface="Liberation Sans"/>
               </a:rPr>
-              <a:t>Draft Copy Honesty: </a:t>
-            </a:r>
-            <a:r>
-              <a:rPr sz="1150" b="0">
+              <a:t>Honest Copy Status: </a:t>
+            </a:r>
+            <a:r>
+              <a:rPr sz="1140" b="0">
                 <a:solidFill>
                   <a:srgbClr val="0F172A"/>
                 </a:solidFill>
                 <a:latin typeface="Liberation Sans"/>
               </a:rPr>
-              <a:t>Kannada &amp; Hindi carry visible [DRAFT - UNREVIEWED] badges until 3-merchant teach-back sign-off.</a:t>
+              <a:t>EN author-checked, native review pending; KN &amp; HI carry visible [DRAFT - UNREVIEWED] badges.</a:t>
             </a:r>
           </a:p>
         </p:txBody>
@@ -11676,7 +11676,7 @@
               <a:buChar char="•"/>
             </a:pPr>
             <a:r>
-              <a:rPr sz="1150" b="1">
+              <a:rPr sz="1140" b="1">
                 <a:solidFill>
                   <a:srgbClr val="002970"/>
                 </a:solidFill>
@@ -11685,7 +11685,7 @@
               <a:t>ITT &amp; Wilson 95% CIs: </a:t>
             </a:r>
             <a:r>
-              <a:rPr sz="1150" b="0">
+              <a:rPr sz="1140" b="0">
                 <a:solidFill>
                   <a:srgbClr val="0F172A"/>
                 </a:solidFill>
@@ -11702,22 +11702,22 @@
               <a:buChar char="•"/>
             </a:pPr>
             <a:r>
-              <a:rPr sz="1150" b="1">
+              <a:rPr sz="1140" b="1">
                 <a:solidFill>
                   <a:srgbClr val="002970"/>
                 </a:solidFill>
                 <a:latin typeface="Liberation Sans"/>
               </a:rPr>
-              <a:t>Power Calculator: </a:t>
-            </a:r>
-            <a:r>
-              <a:rPr sz="1150" b="0">
+              <a:t>Pooled Pilot Power: </a:t>
+            </a:r>
+            <a:r>
+              <a:rPr sz="1140" b="0">
                 <a:solidFill>
                   <a:srgbClr val="0F172A"/>
                 </a:solidFill>
                 <a:latin typeface="Liberation Sans"/>
               </a:rPr>
-              <a:t>80/20 split (r=4): 31C + 124T = 155 (~4 waves); 50/50 split (r=1): 46C + 46T = 92.</a:t>
+              <a:t>50 shops x 1 wave (400C + 1,600T): 50.3%, 68.8%, 83.3%, 92.5%, 97.2%, 99.8% at +4..+10 pp.</a:t>
             </a:r>
           </a:p>
           <a:p>
@@ -11728,7 +11728,7 @@
               <a:buChar char="•"/>
             </a:pPr>
             <a:r>
-              <a:rPr sz="1150" b="1">
+              <a:rPr sz="1140" b="1">
                 <a:solidFill>
                   <a:srgbClr val="002970"/>
                 </a:solidFill>
@@ -11737,7 +11737,7 @@
               <a:t>Cap Risk &amp; Refusals: </a:t>
             </a:r>
             <a:r>
-              <a:rPr sz="1150" b="0">
+              <a:rPr sz="1140" b="0">
                 <a:solidFill>
                   <a:srgbClr val="0F172A"/>
                 </a:solidFill>
@@ -11754,7 +11754,7 @@
               <a:buChar char="•"/>
             </a:pPr>
             <a:r>
-              <a:rPr sz="1150" b="1">
+              <a:rPr sz="1140" b="1">
                 <a:solidFill>
                   <a:srgbClr val="002970"/>
                 </a:solidFill>
@@ -11763,7 +11763,7 @@
               <a:t>Banned Merchant Terms: </a:t>
             </a:r>
             <a:r>
-              <a:rPr sz="1150" b="0">
+              <a:rPr sz="1140" b="0">
                 <a:solidFill>
                   <a:srgbClr val="0F172A"/>
                 </a:solidFill>
@@ -12459,7 +12459,7 @@
                 </a:solidFill>
                 <a:latin typeface="Liberation Sans"/>
               </a:rPr>
-              <a:t>Paytm Build for India AI Hackathon (Bengaluru Track 1) | Traced to results/slide_numbers.md (Paytm Q2 FY27)</a:t>
+              <a:t>Paytm Build for India AI Hackathon (Bengaluru Track 1) | Traced to results/slide_numbers.md (Deck v2.1)</a:t>
             </a:r>
           </a:p>
         </p:txBody>
@@ -12574,12 +12574,12 @@
           <a:p>
             <a:pPr marL="210000" indent="-210000">
               <a:spcAft>
-                <a:spcPts val="1100"/>
+                <a:spcPts val="1000"/>
               </a:spcAft>
               <a:buChar char="•"/>
             </a:pPr>
             <a:r>
-              <a:rPr sz="1200" b="1">
+              <a:rPr sz="1160" b="1">
                 <a:solidFill>
                   <a:srgbClr val="002970"/>
                 </a:solidFill>
@@ -12588,24 +12588,24 @@
               <a:t>Merchant Cashback Stop: </a:t>
             </a:r>
             <a:r>
-              <a:rPr sz="1200" b="0">
+              <a:rPr sz="1160" b="0">
                 <a:solidFill>
                   <a:srgbClr val="0F172A"/>
                 </a:solidFill>
                 <a:latin typeface="Liberation Sans"/>
               </a:rPr>
-              <a:t>Issues passes to all 32 nudged buyers; atomic SQLite lock stops spend at Rs 300 (12 paid) and records cap_reached + refused_redemptions.</a:t>
+              <a:t>Issues passes ('valid while budget lasts') to all 32 nudged buyers; SQLite lock stops spend at Rs 300 (12 paid) and logs declines.</a:t>
             </a:r>
           </a:p>
           <a:p>
             <a:pPr marL="210000" indent="-210000">
               <a:spcAft>
-                <a:spcPts val="1100"/>
+                <a:spcPts val="1000"/>
               </a:spcAft>
               <a:buChar char="•"/>
             </a:pPr>
             <a:r>
-              <a:rPr sz="1200" b="1">
+              <a:rPr sz="1160" b="1">
                 <a:solidFill>
                   <a:srgbClr val="002970"/>
                 </a:solidFill>
@@ -12614,7 +12614,7 @@
               <a:t>Dose-Response Sweet Spot: </a:t>
             </a:r>
             <a:r>
-              <a:rPr sz="1200" b="0">
+              <a:rPr sz="1160" b="0">
                 <a:solidFill>
                   <a:srgbClr val="0F172A"/>
                 </a:solidFill>
@@ -12626,38 +12626,38 @@
           <a:p>
             <a:pPr marL="210000" indent="-210000">
               <a:spcAft>
-                <a:spcPts val="1100"/>
+                <a:spcPts val="1000"/>
               </a:spcAft>
               <a:buChar char="•"/>
             </a:pPr>
             <a:r>
-              <a:rPr sz="1200" b="1">
+              <a:rPr sz="1160" b="1">
                 <a:solidFill>
                   <a:srgbClr val="002970"/>
                 </a:solidFill>
                 <a:latin typeface="Liberation Sans"/>
               </a:rPr>
-              <a:t>Shop Margin Break-Even: </a:t>
-            </a:r>
-            <a:r>
-              <a:rPr sz="1200" b="0">
+              <a:t>Margin &amp; Lift Break-Even: </a:t>
+            </a:r>
+            <a:r>
+              <a:rPr sz="1160" b="0">
                 <a:solidFill>
                   <a:srgbClr val="0F172A"/>
                 </a:solidFill>
                 <a:latin typeface="Liberation Sans"/>
               </a:rPr>
-              <a:t>On CMP-WINBACK-01, store breaks even at 17.2% gross margin pre-fee and 24.7% post-5%-fee; 30% darshini margin nets +Rs 91.50 post-fee.</a:t>
+              <a:t>At +25 pp simulated lift, shop breaks even at 17.2% margin pre-fee (24.7% post-fee); at 30% margin, break-even lift is +7.8 pp pre-fee (+15.3 pp post-fee).</a:t>
             </a:r>
           </a:p>
           <a:p>
             <a:pPr marL="210000" indent="-210000">
               <a:spcAft>
-                <a:spcPts val="1100"/>
+                <a:spcPts val="1000"/>
               </a:spcAft>
               <a:buChar char="•"/>
             </a:pPr>
             <a:r>
-              <a:rPr sz="1200" b="1">
+              <a:rPr sz="1160" b="1">
                 <a:solidFill>
                   <a:srgbClr val="002970"/>
                 </a:solidFill>
@@ -12666,7 +12666,7 @@
               <a:t>Sarvam 30% Credit Ledger: </a:t>
             </a:r>
             <a:r>
-              <a:rPr sz="1200" b="0">
+              <a:rPr sz="1160" b="0">
                 <a:solidFill>
                   <a:srgbClr val="0F172A"/>
                 </a:solidFill>
@@ -12678,12 +12678,12 @@
           <a:p>
             <a:pPr marL="210000" indent="-210000">
               <a:spcAft>
-                <a:spcPts val="1100"/>
+                <a:spcPts val="1000"/>
               </a:spcAft>
               <a:buChar char="•"/>
             </a:pPr>
             <a:r>
-              <a:rPr sz="1200" b="1">
+              <a:rPr sz="1160" b="1">
                 <a:solidFill>
                   <a:srgbClr val="002970"/>
                 </a:solidFill>
@@ -12692,7 +12692,7 @@
               <a:t>Public Cloud Lock: </a:t>
             </a:r>
             <a:r>
-              <a:rPr sz="1200" b="0">
+              <a:rPr sz="1160" b="0">
                 <a:solidFill>
                   <a:srgbClr val="0F172A"/>
                 </a:solidFill>
@@ -12849,7 +12849,7 @@
               </a:spcAft>
             </a:pPr>
             <a:r>
-              <a:rPr sz="1100" b="1" i="0">
+              <a:rPr sz="1080" b="1" i="0">
                 <a:solidFill>
                   <a:srgbClr val="FFFFFF"/>
                 </a:solidFill>
@@ -12865,13 +12865,13 @@
               </a:spcAft>
             </a:pPr>
             <a:r>
-              <a:rPr sz="1100" b="1" i="0">
+              <a:rPr sz="1080" b="1" i="0">
                 <a:solidFill>
                   <a:srgbClr val="FFFFFF"/>
                 </a:solidFill>
                 <a:latin typeface="Liberation Sans"/>
               </a:rPr>
-              <a:t>1. Merchant Cap: Protects shopkeeper pocket (Rs 300 stop; &gt;10% overrun warning).</a:t>
+              <a:t>1. Merchant Cap: Protects shopkeeper pocket (Rs 300 stop; &gt;10% overrun warning &amp; 80% top-up prompt).</a:t>
             </a:r>
           </a:p>
           <a:p>
@@ -12881,7 +12881,7 @@
               </a:spcAft>
             </a:pPr>
             <a:r>
-              <a:rPr sz="1100" b="1" i="0">
+              <a:rPr sz="1080" b="1" i="0">
                 <a:solidFill>
                   <a:srgbClr val="FFFFFF"/>
                 </a:solidFill>
@@ -13202,7 +13202,7 @@
                 </a:solidFill>
                 <a:latin typeface="Liberation Sans"/>
               </a:rPr>
-              <a:t>Paytm Build for India AI Hackathon (Bengaluru Track 1) | Traced to results/slide_numbers.md (Paytm Q2 FY27)</a:t>
+              <a:t>Paytm Build for India AI Hackathon (Bengaluru Track 1) | Traced to results/slide_numbers.md (Deck v2.1)</a:t>
             </a:r>
           </a:p>
         </p:txBody>
@@ -13337,7 +13337,7 @@
                 </a:solidFill>
                 <a:latin typeface="Liberation Sans"/>
               </a:rPr>
-              <a:t>Speaks 8:30 PM brief in English, Kannada, or Hindi (KN/HI marked Draft; zero jargon).</a:t>
+              <a:t>EN author-checked, native review pending; KN/HI draft; zero jargon.</a:t>
             </a:r>
           </a:p>
           <a:p>
@@ -13380,7 +13380,7 @@
                 </a:solidFill>
                 <a:latin typeface="Liberation Sans"/>
               </a:rPr>
-              <a:t>Policy &amp; ITT Split: </a:t>
+              <a:t>Policy &amp; 80/20 Split: </a:t>
             </a:r>
             <a:r>
               <a:rPr sz="1800" b="0">
@@ -13415,7 +13415,7 @@
                 </a:solidFill>
                 <a:latin typeface="Liberation Sans"/>
               </a:rPr>
-              <a:t>All 32 nudged get Rs 25 pass (Rs 800 face); hard stop at Rs 300 spend (&gt;10% risk alert).</a:t>
+              <a:t>All 32 nudged get Rs 25 pass (valid while budget lasts); hard stop at Rs 300 (&gt;10% alert).</a:t>
             </a:r>
           </a:p>
           <a:p>
@@ -13666,8 +13666,8 @@
         </p:nvSpPr>
         <p:spPr>
           <a:xfrm>
-            <a:off x="8028431" y="4645152"/>
-            <a:ext cx="3474720" cy="1426464"/>
+            <a:off x="8028431" y="4626864"/>
+            <a:ext cx="3474720" cy="1463040"/>
           </a:xfrm>
           <a:prstGeom prst="roundRect">
             <a:avLst>
@@ -13713,8 +13713,8 @@
         </p:nvSpPr>
         <p:spPr>
           <a:xfrm>
-            <a:off x="8156448" y="4736592"/>
-            <a:ext cx="3218688" cy="1261872"/>
+            <a:off x="8138160" y="4709160"/>
+            <a:ext cx="3255264" cy="1316736"/>
           </a:xfrm>
           <a:prstGeom prst="rect">
             <a:avLst/>
@@ -13733,7 +13733,7 @@
               </a:spcAft>
             </a:pPr>
             <a:r>
-              <a:rPr sz="1150" b="0" i="0">
+              <a:rPr sz="1100" b="0" i="0">
                 <a:solidFill>
                   <a:srgbClr val="E0F7FE"/>
                 </a:solidFill>
@@ -13749,13 +13749,13 @@
               </a:spcAft>
             </a:pPr>
             <a:r>
-              <a:rPr sz="1150" b="0" i="0">
+              <a:rPr sz="1100" b="0" i="0">
                 <a:solidFill>
                   <a:srgbClr val="E0F7FE"/>
                 </a:solidFill>
                 <a:latin typeface="Liberation Sans"/>
               </a:rPr>
-              <a:t>Isolated SQLite session per visitor.</a:t>
+              <a:t>Isolated SQLite per visitor (30m TTL,</a:t>
             </a:r>
           </a:p>
           <a:p>
@@ -13765,29 +13765,29 @@
               </a:spcAft>
             </a:pPr>
             <a:r>
-              <a:rPr sz="1150" b="0" i="0">
+              <a:rPr sz="1100" b="0" i="0">
                 <a:solidFill>
                   <a:srgbClr val="E0F7FE"/>
                 </a:solidFill>
                 <a:latin typeface="Liberation Sans"/>
               </a:rPr>
+              <a:t>64-session LRU, 2MB/32MB disk caps).</a:t>
+            </a:r>
+          </a:p>
+          <a:p>
+            <a:pPr algn="ctr">
+              <a:spcAft>
+                <a:spcPts val="300"/>
+              </a:spcAft>
+            </a:pPr>
+            <a:r>
+              <a:rPr sz="1100" b="0" i="0">
+                <a:solidFill>
+                  <a:srgbClr val="E0F7FE"/>
+                </a:solidFill>
+                <a:latin typeface="Liberation Sans"/>
+              </a:rPr>
               <a:t>Zero paid API calls on public URL.</a:t>
-            </a:r>
-          </a:p>
-          <a:p>
-            <a:pPr algn="ctr">
-              <a:spcAft>
-                <a:spcPts val="300"/>
-              </a:spcAft>
-            </a:pPr>
-            <a:r>
-              <a:rPr sz="1150" b="0" i="0">
-                <a:solidFill>
-                  <a:srgbClr val="E0F7FE"/>
-                </a:solidFill>
-                <a:latin typeface="Liberation Sans"/>
-              </a:rPr>
-              <a:t>Switch Merchant vs Technical View.</a:t>
             </a:r>
           </a:p>
         </p:txBody>
@@ -14102,7 +14102,7 @@
                 </a:solidFill>
                 <a:latin typeface="Liberation Sans"/>
               </a:rPr>
-              <a:t>Paytm Build for India AI Hackathon (Bengaluru Track 1) | Traced to results/slide_numbers.md (Paytm Q2 FY27)</a:t>
+              <a:t>Paytm Build for India AI Hackathon (Bengaluru Track 1) | Traced to results/slide_numbers.md (Deck v2.1)</a:t>
             </a:r>
           </a:p>
         </p:txBody>
@@ -14228,7 +14228,7 @@
                 </a:solidFill>
                 <a:latin typeface="Liberation Sans"/>
               </a:rPr>
-              <a:t>[BUILT IN STAGE 1] ITT Stats &amp; Atomic Cap Engine: </a:t>
+              <a:t>[BUILT] ITT Stats &amp; Atomic Cap Engine: </a:t>
             </a:r>
             <a:r>
               <a:rPr sz="1820" b="0">
@@ -14237,7 +14237,7 @@
                 </a:solidFill>
                 <a:latin typeface="Liberation Sans"/>
               </a:rPr>
-              <a:t>Fisher exact p, Wilson 95% CIs, allocation-ratio power, atomic BEGIN IMMEDIATE spend stop, 25-thread concurrency test.</a:t>
+              <a:t>Fisher exact p, Wilson 95% CIs, pooled/unequal power math, atomic BEGIN IMMEDIATE spend stop, 25-thread concurrency test.</a:t>
             </a:r>
           </a:p>
           <a:p>
@@ -14254,7 +14254,7 @@
                 </a:solidFill>
                 <a:latin typeface="Liberation Sans"/>
               </a:rPr>
-              <a:t>[BUILT IN STAGE 1] Merchant Copy &amp; Isolation: </a:t>
+              <a:t>[BUILT] Merchant Copy &amp; Cloud Sandboxes: </a:t>
             </a:r>
             <a:r>
               <a:rPr sz="1820" b="0">
@@ -14263,7 +14263,7 @@
                 </a:solidFill>
                 <a:latin typeface="Liberation Sans"/>
               </a:rPr>
-              <a:t>Merchant vs Technical View, banned-jargon lint, Evidence Grades A/B/C, per-visitor SQLite sandboxes, ADMIN_TOKEN gate.</a:t>
+              <a:t>Merchant vs Technical View, banned-jargon lint, Evidence Grades A/B/C, TTL/LRU/byte-bounded visitor SQLite sessions.</a:t>
             </a:r>
           </a:p>
           <a:p>
@@ -14401,7 +14401,7 @@
                 </a:solidFill>
                 <a:latin typeface="Liberation Sans"/>
               </a:rPr>
-              <a:t>make preflight : PASS</a:t>
+              <a:t>Automated Release Guards</a:t>
             </a:r>
           </a:p>
         </p:txBody>
@@ -14440,7 +14440,7 @@
                 </a:solidFill>
                 <a:latin typeface="Liberation Sans"/>
               </a:rPr>
-              <a:t>Zero leaked keys, render.yaml untouched, zero formatting errors, 21/21 QA battery green.</a:t>
+              <a:t>Pre-release checks scan for secret keys, banned merchant jargon, and 21 QA assertions.</a:t>
             </a:r>
           </a:p>
         </p:txBody>
@@ -14526,7 +14526,7 @@
                 </a:solidFill>
                 <a:latin typeface="Liberation Sans"/>
               </a:rPr>
-              <a:t>25-Thread Lock : PASS</a:t>
+              <a:t>Atomic Spend-Stop Lock</a:t>
             </a:r>
           </a:p>
         </p:txBody>
@@ -14565,7 +14565,7 @@
                 </a:solidFill>
                 <a:latin typeface="Liberation Sans"/>
               </a:rPr>
-              <a:t>Simultaneous QR redemptions stop at exact Rs 300 cap; ITT lift invariant when cap binds.</a:t>
+              <a:t>SQLite write locking stops simultaneous QR scans at the exact merchant rupee cap.</a:t>
             </a:r>
           </a:p>
         </p:txBody>
@@ -14651,7 +14651,7 @@
                 </a:solidFill>
                 <a:latin typeface="Liberation Sans"/>
               </a:rPr>
-              <a:t>Cloud Sandbox : PASS</a:t>
+              <a:t>Bounded Visitor Sandboxes</a:t>
             </a:r>
           </a:p>
         </p:txBody>
@@ -14690,7 +14690,7 @@
                 </a:solidFill>
                 <a:latin typeface="Liberation Sans"/>
               </a:rPr>
-              <a:t>PUBLIC_DEPLOY=true blocks paid APIs; concurrent visitors get isolated SQLite files.</a:t>
+              <a:t>Per-visitor SQLite files enforce 30-min TTL, 64-session LRU eviction, and 32 MB disk cap.</a:t>
             </a:r>
           </a:p>
         </p:txBody>
@@ -15005,7 +15005,7 @@
                 </a:solidFill>
                 <a:latin typeface="Liberation Sans"/>
               </a:rPr>
-              <a:t>Paytm Build for India AI Hackathon (Bengaluru Track 1) | Traced to results/slide_numbers.md (Paytm Q2 FY27)</a:t>
+              <a:t>Paytm Build for India AI Hackathon (Bengaluru Track 1) | Traced to results/slide_numbers.md (Deck v2.1)</a:t>
             </a:r>
           </a:p>
         </p:txBody>
@@ -15058,7 +15058,7 @@
         <p:spPr>
           <a:xfrm>
             <a:off x="502920" y="1188720"/>
-            <a:ext cx="6629400" cy="4370832"/>
+            <a:ext cx="6629400" cy="4334256"/>
           </a:xfrm>
           <a:prstGeom prst="roundRect">
             <a:avLst>
@@ -15105,7 +15105,7 @@
         <p:spPr>
           <a:xfrm>
             <a:off x="658368" y="1298448"/>
-            <a:ext cx="6327648" cy="4187952"/>
+            <a:ext cx="6327648" cy="4151376"/>
           </a:xfrm>
           <a:prstGeom prst="rect">
             <a:avLst/>
@@ -15157,7 +15157,7 @@
                 </a:solidFill>
                 <a:latin typeface="Liberation Sans"/>
               </a:rPr>
-              <a:t>80% Power Target: </a:t>
+              <a:t>Sample Requirement: </a:t>
             </a:r>
             <a:r>
               <a:rPr sz="1800" b="0">
@@ -15166,7 +15166,7 @@
                 </a:solidFill>
                 <a:latin typeface="Liberation Sans"/>
               </a:rPr>
-              <a:t>At 80/20 (40/wave): ~31 control + ~124 nudged (155 total, ~4 waves), or 46/arm at 50/50 split.</a:t>
+              <a:t>Single wave (N=40) is directional; 25 pp lift needs 31C + 124T = 155 (~4 store-waves) or 46/arm at 50/50.</a:t>
             </a:r>
           </a:p>
           <a:p>
@@ -15257,8 +15257,8 @@
         </p:nvSpPr>
         <p:spPr>
           <a:xfrm>
-            <a:off x="502920" y="5669280"/>
-            <a:ext cx="6629400" cy="594360"/>
+            <a:off x="502920" y="5614416"/>
+            <a:ext cx="6629400" cy="658368"/>
           </a:xfrm>
           <a:prstGeom prst="roundRect">
             <a:avLst>
@@ -15304,8 +15304,8 @@
         </p:nvSpPr>
         <p:spPr>
           <a:xfrm>
-            <a:off x="658368" y="5779008"/>
-            <a:ext cx="6327648" cy="384048"/>
+            <a:off x="640080" y="5678424"/>
+            <a:ext cx="6364224" cy="530352"/>
           </a:xfrm>
           <a:prstGeom prst="rect">
             <a:avLst/>
@@ -15324,13 +15324,13 @@
               </a:spcAft>
             </a:pPr>
             <a:r>
-              <a:rPr sz="1250" b="1" i="0">
+              <a:rPr sz="1100" b="1" i="0">
                 <a:solidFill>
                   <a:srgbClr val="002970"/>
                 </a:solidFill>
                 <a:latin typeface="Liberation Sans"/>
               </a:rPr>
-              <a:t>ITT Invariance Verified: Outcomes are drawn before applying the spend stop, so holdout lift stays unchanged if the cap binds.</a:t>
+              <a:t>Intention-to-Treat (ITT) Definition: Compares all 32 assigned nudged buyers vs all 8 assigned silent controls regardless of redemption or cap stops, preventing selection bias and keeping lift invariant if the cap binds.</a:t>
             </a:r>
           </a:p>
         </p:txBody>
@@ -15415,7 +15415,7 @@
         <p:spPr>
           <a:xfrm>
             <a:off x="7315200" y="4535424"/>
-            <a:ext cx="4370832" cy="1728216"/>
+            <a:ext cx="4370832" cy="1737360"/>
           </a:xfrm>
           <a:prstGeom prst="roundRect">
             <a:avLst>
@@ -15461,8 +15461,8 @@
         </p:nvSpPr>
         <p:spPr>
           <a:xfrm>
-            <a:off x="7461504" y="4645152"/>
-            <a:ext cx="4078224" cy="1517904"/>
+            <a:off x="7461504" y="4626864"/>
+            <a:ext cx="4078224" cy="1572768"/>
           </a:xfrm>
           <a:prstGeom prst="rect">
             <a:avLst/>
@@ -15481,7 +15481,7 @@
               </a:spcAft>
             </a:pPr>
             <a:r>
-              <a:rPr sz="1180" b="1" i="0">
+              <a:rPr sz="1100" b="1" i="0">
                 <a:solidFill>
                   <a:srgbClr val="0F172A"/>
                 </a:solidFill>
@@ -15497,7 +15497,7 @@
               </a:spcAft>
             </a:pPr>
             <a:r>
-              <a:rPr sz="1180" b="1" i="0">
+              <a:rPr sz="1100" b="1" i="0">
                 <a:solidFill>
                   <a:srgbClr val="0F172A"/>
                 </a:solidFill>
@@ -15513,13 +15513,29 @@
               </a:spcAft>
             </a:pPr>
             <a:r>
-              <a:rPr sz="1180" b="1" i="0">
+              <a:rPr sz="1100" b="1" i="0">
                 <a:solidFill>
                   <a:srgbClr val="0F172A"/>
                 </a:solidFill>
                 <a:latin typeface="Liberation Sans"/>
               </a:rPr>
-              <a:t>Break-even shop margin: 17.2% pre-fee | 24.7% post-fee.</a:t>
+              <a:t>Break-even margin: 17.2% pre-fee | 24.7% post-fee.</a:t>
+            </a:r>
+          </a:p>
+          <a:p>
+            <a:pPr algn="l">
+              <a:spcAft>
+                <a:spcPts val="300"/>
+              </a:spcAft>
+            </a:pPr>
+            <a:r>
+              <a:rPr sz="1100" b="1" i="0">
+                <a:solidFill>
+                  <a:srgbClr val="0F172A"/>
+                </a:solidFill>
+                <a:latin typeface="Liberation Sans"/>
+              </a:rPr>
+              <a:t>Break-even lift (30% margin): +7.8 pp pre | +15.3 pp post.</a:t>
             </a:r>
           </a:p>
         </p:txBody>
@@ -15602,7 +15618,7 @@
         <p:spPr>
           <a:xfrm>
             <a:off x="502920" y="219456"/>
-            <a:ext cx="3931920" cy="292608"/>
+            <a:ext cx="4105656" cy="292608"/>
           </a:xfrm>
           <a:prstGeom prst="roundRect">
             <a:avLst>
@@ -15649,7 +15665,7 @@
         <p:spPr>
           <a:xfrm>
             <a:off x="548640" y="246888"/>
-            <a:ext cx="3840480" cy="237744"/>
+            <a:ext cx="4014216" cy="237744"/>
           </a:xfrm>
           <a:prstGeom prst="rect">
             <a:avLst/>
@@ -15674,7 +15690,7 @@
                 </a:solidFill>
                 <a:latin typeface="Liberation Sans"/>
               </a:rPr>
-              <a:t>MAIN 5 / 5 : BUSINESS MODEL &amp; PILOT PLAN</a:t>
+              <a:t>MAIN 5 / 5 : BUSINESS MODEL &amp; POOLED PILOT</a:t>
             </a:r>
           </a:p>
         </p:txBody>
@@ -15752,7 +15768,7 @@
                 </a:solidFill>
                 <a:latin typeface="Liberation Sans"/>
               </a:rPr>
-              <a:t>Three Revenue Cases (5% of 1.64 Cr Q2 Base = 8.20L Shops)</a:t>
+              <a:t>Three Revenue Cases (8.20L Shops) &amp; 50-Shop Pooled Pilot</a:t>
             </a:r>
           </a:p>
         </p:txBody>
@@ -15834,7 +15850,7 @@
                 </a:solidFill>
                 <a:latin typeface="Liberation Sans"/>
               </a:rPr>
-              <a:t>Paytm Build for India AI Hackathon (Bengaluru Track 1) | Traced to results/slide_numbers.md (Paytm Q2 FY27)</a:t>
+              <a:t>Paytm Build for India AI Hackathon (Bengaluru Track 1) | Traced to results/slide_numbers.md (Deck v2.1)</a:t>
             </a:r>
           </a:p>
         </p:txBody>
@@ -15887,7 +15903,7 @@
         <p:spPr>
           <a:xfrm>
             <a:off x="502920" y="1188720"/>
-            <a:ext cx="6629400" cy="4370832"/>
+            <a:ext cx="6629400" cy="4334256"/>
           </a:xfrm>
           <a:prstGeom prst="roundRect">
             <a:avLst>
@@ -15934,7 +15950,7 @@
         <p:spPr>
           <a:xfrm>
             <a:off x="658368" y="1298448"/>
-            <a:ext cx="6327648" cy="4187952"/>
+            <a:ext cx="6327648" cy="4151376"/>
           </a:xfrm>
           <a:prstGeom prst="rect">
             <a:avLst/>
@@ -16064,7 +16080,7 @@
                 </a:solidFill>
                 <a:latin typeface="Liberation Sans"/>
               </a:rPr>
-              <a:t>Powered 4-Week Pilot: </a:t>
+              <a:t>Pooled 50-Shop Pilot: </a:t>
             </a:r>
             <a:r>
               <a:rPr sz="1800" b="0">
@@ -16073,7 +16089,7 @@
                 </a:solidFill>
                 <a:latin typeface="Liberation Sans"/>
               </a:rPr>
-              <a:t>50 Bengaluru shops; 4 waves/shop (~160 &gt;= 155 needed at 80/20) + native KN/HI teach-back.</a:t>
+              <a:t>50 shops x 1 wave (~400C + ~1,600T, stratified by shop): 83.3% power at +6 pp, 97.2% at +8 pp.</a:t>
             </a:r>
           </a:p>
         </p:txBody>
@@ -16086,8 +16102,8 @@
         </p:nvSpPr>
         <p:spPr>
           <a:xfrm>
-            <a:off x="502920" y="5669280"/>
-            <a:ext cx="6629400" cy="594360"/>
+            <a:off x="502920" y="5614416"/>
+            <a:ext cx="6629400" cy="658368"/>
           </a:xfrm>
           <a:prstGeom prst="roundRect">
             <a:avLst>
@@ -16133,8 +16149,8 @@
         </p:nvSpPr>
         <p:spPr>
           <a:xfrm>
-            <a:off x="658368" y="5779008"/>
-            <a:ext cx="6327648" cy="384048"/>
+            <a:off x="640080" y="5687568"/>
+            <a:ext cx="6364224" cy="512064"/>
           </a:xfrm>
           <a:prstGeom prst="rect">
             <a:avLst/>
@@ -16153,13 +16169,13 @@
               </a:spcAft>
             </a:pPr>
             <a:r>
-              <a:rPr sz="1200" b="1" i="0">
+              <a:rPr sz="1080" b="1" i="0">
                 <a:solidFill>
                   <a:srgbClr val="0F172A"/>
                 </a:solidFill>
                 <a:latin typeface="Liberation Sans"/>
               </a:rPr>
-              <a:t>Fee Reconciliation: Single backlog wave = Rs 130.50 (5% of Rs 2,610); steady state = Rs 102/mo (~0.78 waves/mo as 14d pool refills).</a:t>
+              <a:t>Why Pool 50 Shops (Not 4 Waves/Shop): 14d cooldown &amp; ~0.78 waves/mo replenishment preclude 4 weekly waves in 1 shop; pooling 50x1 gives 50.3%/68.8%/83.3%/92.5%/97.2%/99.8% power at +4/+5/+6/+7/+8/+10 pp.</a:t>
             </a:r>
           </a:p>
         </p:txBody>
@@ -16244,7 +16260,7 @@
         <p:spPr>
           <a:xfrm>
             <a:off x="7315200" y="4535424"/>
-            <a:ext cx="4370832" cy="1728216"/>
+            <a:ext cx="4370832" cy="1737360"/>
           </a:xfrm>
           <a:prstGeom prst="roundRect">
             <a:avLst>
@@ -16310,13 +16326,13 @@
               </a:spcAft>
             </a:pPr>
             <a:r>
-              <a:rPr sz="1180" b="1" i="0">
+              <a:rPr sz="1150" b="1" i="0">
                 <a:solidFill>
                   <a:srgbClr val="FFFFFF"/>
                 </a:solidFill>
                 <a:latin typeface="Liberation Sans"/>
               </a:rPr>
-              <a:t>Q2 FY27 BASE &amp; TTS CACHE NOTE</a:t>
+              <a:t>Q2 FY27 BASE &amp; FEE RECONCILIATION</a:t>
             </a:r>
           </a:p>
           <a:p>
@@ -16326,7 +16342,7 @@
               </a:spcAft>
             </a:pPr>
             <a:r>
-              <a:rPr sz="1180" b="1" i="0">
+              <a:rPr sz="1150" b="1" i="0">
                 <a:solidFill>
                   <a:srgbClr val="FFFFFF"/>
                 </a:solidFill>
@@ -16342,13 +16358,13 @@
               </a:spcAft>
             </a:pPr>
             <a:r>
-              <a:rPr sz="1180" b="1" i="0">
+              <a:rPr sz="1150" b="1" i="0">
                 <a:solidFill>
                   <a:srgbClr val="FFFFFF"/>
                 </a:solidFill>
                 <a:latin typeface="Liberation Sans"/>
               </a:rPr>
-              <a:t>Bulbul v3 = Rs 27/mo uncached (9k chars); ~88% phrase cache hit yields Rs 3.20/mo TTS.</a:t>
+              <a:t>1 backlog wave = Rs 130.50 fee; steady state (~0.78 waves/mo) = Rs 102/mo.</a:t>
             </a:r>
           </a:p>
         </p:txBody>
@@ -16739,13 +16755,13 @@
               </a:spcAft>
             </a:pPr>
             <a:r>
-              <a:rPr sz="980" b="0" i="0">
+              <a:rPr sz="960" b="0" i="0">
                 <a:solidFill>
                   <a:srgbClr val="BAE6FD"/>
                 </a:solidFill>
                 <a:latin typeface="Liberation Sans"/>
               </a:rPr>
-              <a:t>EN reviewed + KN/HI draft templates; banned-jargon lint</a:t>
+              <a:t>EN author-checked, native review pending; KN/HI draft</a:t>
             </a:r>
           </a:p>
         </p:txBody>
@@ -16864,7 +16880,7 @@
               </a:spcAft>
             </a:pPr>
             <a:r>
-              <a:rPr sz="980" b="0" i="0">
+              <a:rPr sz="960" b="0" i="0">
                 <a:solidFill>
                   <a:srgbClr val="BAE6FD"/>
                 </a:solidFill>
@@ -16956,7 +16972,7 @@
                 </a:solidFill>
                 <a:latin typeface="Liberation Sans"/>
               </a:rPr>
-              <a:t>03 : Profit &amp; Power Audit</a:t>
+              <a:t>03 : 50-Shop Pooled Pilot</a:t>
             </a:r>
           </a:p>
         </p:txBody>
@@ -16989,13 +17005,13 @@
               </a:spcAft>
             </a:pPr>
             <a:r>
-              <a:rPr sz="980" b="0" i="0">
+              <a:rPr sz="960" b="0" i="0">
                 <a:solidFill>
                   <a:srgbClr val="BAE6FD"/>
                 </a:solidFill>
                 <a:latin typeface="Liberation Sans"/>
               </a:rPr>
-              <a:t>+Rs 222 pre-fee / +Rs 91.50 post-fee; 31C+124T (80/20) for 80% power</a:t>
+              <a:t>+Rs 91.50 post-fee; 400C+1,600T gives 83.3% power at +6 pp lift</a:t>
             </a:r>
           </a:p>
         </p:txBody>
@@ -17120,7 +17136,7 @@
                 </a:solidFill>
                 <a:latin typeface="Liberation Sans"/>
               </a:rPr>
-              <a:t>Deck v2 Status: Stage 1 verified (stage1-ok); all Q2 FY27, ITT cap, power, and fee reconciliations applied.</a:t>
+              <a:t>Deck v2.1 Status: Stage 1 verified (stage1-ok); pooled 50-shop power, ITT definition, and copy disclosures applied.</a:t>
             </a:r>
           </a:p>
         </p:txBody>
@@ -17435,7 +17451,7 @@
                 </a:solidFill>
                 <a:latin typeface="Liberation Sans"/>
               </a:rPr>
-              <a:t>Paytm Build for India AI Hackathon (Bengaluru Track 1) | Traced to results/slide_numbers.md (Paytm Q2 FY27)</a:t>
+              <a:t>Paytm Build for India AI Hackathon (Bengaluru Track 1) | Traced to results/slide_numbers.md (Deck v2.1)</a:t>
             </a:r>
           </a:p>
         </p:txBody>
@@ -17980,8 +17996,8 @@
         </p:nvSpPr>
         <p:spPr>
           <a:xfrm>
-            <a:off x="6711696" y="4626864"/>
-            <a:ext cx="4846320" cy="1627632"/>
+            <a:off x="6711696" y="4645152"/>
+            <a:ext cx="4846320" cy="1591056"/>
           </a:xfrm>
           <a:prstGeom prst="rect">
             <a:avLst/>
@@ -17996,12 +18012,12 @@
           <a:p>
             <a:pPr marL="210000" indent="-210000">
               <a:spcAft>
-                <a:spcPts val="600"/>
+                <a:spcPts val="700"/>
               </a:spcAft>
               <a:buChar char="•"/>
             </a:pPr>
             <a:r>
-              <a:rPr sz="1050" b="1">
+              <a:rPr sz="1060" b="1">
                 <a:solidFill>
                   <a:srgbClr val="00BAF2"/>
                 </a:solidFill>
@@ -18010,24 +18026,24 @@
               <a:t>Reported (Paytm Q2 FY27, 26 Oct 2026): </a:t>
             </a:r>
             <a:r>
-              <a:rPr sz="1050" b="0">
+              <a:rPr sz="1060" b="0">
                 <a:solidFill>
                   <a:srgbClr val="FFFFFF"/>
                 </a:solidFill>
                 <a:latin typeface="Liberation Sans"/>
               </a:rPr>
-              <a:t>1.64 Cr subscription merchants, Rs 7.1L Cr GMV, Rs 2,648 Cr rev, 8.8L FS customers, &gt;50% repeat merchant loans.</a:t>
+              <a:t>1.64 Cr subscription-paying merchants, Rs 7.1L Cr merchant GMV, Rs 2,648 Cr operating revenue.</a:t>
             </a:r>
           </a:p>
           <a:p>
             <a:pPr marL="210000" indent="-210000">
               <a:spcAft>
-                <a:spcPts val="600"/>
+                <a:spcPts val="700"/>
               </a:spcAft>
               <a:buChar char="•"/>
             </a:pPr>
             <a:r>
-              <a:rPr sz="1050" b="1">
+              <a:rPr sz="1060" b="1">
                 <a:solidFill>
                   <a:srgbClr val="00BAF2"/>
                 </a:solidFill>
@@ -18036,7 +18052,7 @@
               <a:t>Assumptions vs Synthetic: </a:t>
             </a:r>
             <a:r>
-              <a:rPr sz="1050" b="0">
+              <a:rPr sz="1060" b="0">
                 <a:solidFill>
                   <a:srgbClr val="FFFFFF"/>
                 </a:solidFill>
@@ -18357,7 +18373,7 @@
                 </a:solidFill>
                 <a:latin typeface="Liberation Sans"/>
               </a:rPr>
-              <a:t>Paytm Build for India AI Hackathon (Bengaluru Track 1) | Traced to results/slide_numbers.md (Paytm Q2 FY27)</a:t>
+              <a:t>Paytm Build for India AI Hackathon (Bengaluru Track 1) | Traced to results/slide_numbers.md (Deck v2.1)</a:t>
             </a:r>
           </a:p>
         </p:txBody>
@@ -19385,7 +19401,7 @@
                 </a:solidFill>
                 <a:latin typeface="Liberation Sans"/>
               </a:rPr>
-              <a:t>Intention-to-Treat Cap-vs-Holdout Design (Decision 1)</a:t>
+              <a:t>Intention-to-Treat Cap-vs-Holdout &amp; Late-Arrival Handling</a:t>
             </a:r>
           </a:p>
         </p:txBody>
@@ -19467,7 +19483,7 @@
                 </a:solidFill>
                 <a:latin typeface="Liberation Sans"/>
               </a:rPr>
-              <a:t>Paytm Build for India AI Hackathon (Bengaluru Track 1) | Traced to results/slide_numbers.md (Paytm Q2 FY27)</a:t>
+              <a:t>Paytm Build for India AI Hackathon (Bengaluru Track 1) | Traced to results/slide_numbers.md (Deck v2.1)</a:t>
             </a:r>
           </a:p>
         </p:txBody>
@@ -19586,7 +19602,7 @@
               </a:spcAft>
             </a:pPr>
             <a:r>
-              <a:rPr sz="1120" b="1" i="0">
+              <a:rPr sz="1100" b="1" i="0">
                 <a:solidFill>
                   <a:srgbClr val="002970"/>
                 </a:solidFill>
@@ -19625,13 +19641,13 @@
               </a:spcAft>
             </a:pPr>
             <a:r>
-              <a:rPr sz="1100" b="0" i="0">
+              <a:rPr sz="1080" b="0" i="0">
                 <a:solidFill>
                   <a:srgbClr val="0F172A"/>
                 </a:solidFill>
                 <a:latin typeface="Liberation Sans"/>
               </a:rPr>
-              <a:t>Filter 48 -&gt; 40 eligible (80/20: 32 nudged, 8 control). Issue Rs 25 passes to ALL 32 nudged buyers (Rs 800 face exposure); never restrict reach to 12.</a:t>
+              <a:t>Filter 48 -&gt; 40 eligible (80/20: 32 nudged, 8 control). Issue Rs 25 passes ('valid while shop offer budget lasts') to ALL 32 nudged buyers (Rs 800 face).</a:t>
             </a:r>
           </a:p>
         </p:txBody>
@@ -19711,13 +19727,13 @@
               </a:spcAft>
             </a:pPr>
             <a:r>
-              <a:rPr sz="1120" b="1" i="0">
+              <a:rPr sz="1100" b="1" i="0">
                 <a:solidFill>
                   <a:srgbClr val="002970"/>
                 </a:solidFill>
                 <a:latin typeface="Liberation Sans"/>
               </a:rPr>
-              <a:t>STEP 2 : &gt;10% RISK ALERT</a:t>
+              <a:t>STEP 2 : &gt;10% &amp; 80% ALERTS</a:t>
             </a:r>
           </a:p>
         </p:txBody>
@@ -19750,13 +19766,13 @@
               </a:spcAft>
             </a:pPr>
             <a:r>
-              <a:rPr sz="1100" b="0" i="0">
+              <a:rPr sz="1080" b="0" i="0">
                 <a:solidFill>
                   <a:srgbClr val="0F172A"/>
                 </a:solidFill>
                 <a:latin typeface="Liberation Sans"/>
               </a:rPr>
-              <a:t>At approval, compute P(Binomial(32, p) &gt; 12). At p=37.5%, overrun risk is 42.2% (&gt;10% threshold): warn merchant and suggest Rs 400 cap (&lt;=10% risk).</a:t>
+              <a:t>At approval, P(Binomial(32, 0.375) &gt; 12) = 42.2% (&gt;10% alert -&gt; suggests Rs 400 cap). Live at 80% cap (10/12 paid), prompt merchant 1-tap top-up.</a:t>
             </a:r>
           </a:p>
         </p:txBody>
@@ -19836,7 +19852,7 @@
               </a:spcAft>
             </a:pPr>
             <a:r>
-              <a:rPr sz="1120" b="1" i="0">
+              <a:rPr sz="1100" b="1" i="0">
                 <a:solidFill>
                   <a:srgbClr val="002970"/>
                 </a:solidFill>
@@ -19875,7 +19891,7 @@
               </a:spcAft>
             </a:pPr>
             <a:r>
-              <a:rPr sz="1100" b="0" i="0">
+              <a:rPr sz="1080" b="0" i="0">
                 <a:solidFill>
                   <a:srgbClr val="0F172A"/>
                 </a:solidFill>
@@ -19961,13 +19977,13 @@
               </a:spcAft>
             </a:pPr>
             <a:r>
-              <a:rPr sz="1120" b="1" i="0">
+              <a:rPr sz="1100" b="1" i="0">
                 <a:solidFill>
                   <a:srgbClr val="002970"/>
                 </a:solidFill>
                 <a:latin typeface="Liberation Sans"/>
               </a:rPr>
-              <a:t>STEP 4 : ITT EVALUATION</a:t>
+              <a:t>STEP 4 : ITT &amp; DECLINE LOG</a:t>
             </a:r>
           </a:p>
         </p:txBody>
@@ -20000,13 +20016,13 @@
               </a:spcAft>
             </a:pPr>
             <a:r>
-              <a:rPr sz="1100" b="0" i="0">
+              <a:rPr sz="1080" b="0" i="0">
                 <a:solidFill>
                   <a:srgbClr val="0F172A"/>
                 </a:solidFill>
                 <a:latin typeface="Liberation Sans"/>
               </a:rPr>
-              <a:t>Record cap_reached &amp; refused_redemptions (12 = cap, 0 refused in base run; 6 refused at Rs 150 cap). Analyse ITT (32 vs 8): holdout lift is unchanged when cap binds.</a:t>
+              <a:t>After cap, normal UPI clears, cashback withholds, refused_redemptions + audit_log increment (brand risk tracked). ITT (32 vs 8) stays unchanged.</a:t>
             </a:r>
           </a:p>
         </p:txBody>
@@ -20092,7 +20108,7 @@
                 </a:solidFill>
                 <a:latin typeface="Liberation Sans"/>
               </a:rPr>
-              <a:t>DISCLOSED TRADE-OFF &amp; VERIFIED INVARIANCE TESTS</a:t>
+              <a:t>DISCLOSED BRAND RISK &amp; VERIFIED INVARIANCE TESTS</a:t>
             </a:r>
           </a:p>
         </p:txBody>
@@ -20126,22 +20142,22 @@
               <a:buChar char="•"/>
             </a:pPr>
             <a:r>
-              <a:rPr sz="1140" b="1">
+              <a:rPr sz="1120" b="1">
                 <a:solidFill>
                   <a:srgbClr val="002970"/>
                 </a:solidFill>
                 <a:latin typeface="Liberation Sans"/>
               </a:rPr>
-              <a:t>Face Exposure vs Hard Spend Stop: </a:t>
-            </a:r>
-            <a:r>
-              <a:rPr sz="1140" b="0">
+              <a:t>Post-Cap Customer Experience &amp; Brand Risk: </a:t>
+            </a:r>
+            <a:r>
+              <a:rPr sz="1120" b="0">
                 <a:solidFill>
                   <a:srgbClr val="0F172A"/>
                 </a:solidFill>
                 <a:latin typeface="Liberation Sans"/>
               </a:rPr>
-              <a:t>Issuing 32 passes creates Rs 800 face exposure while guaranteeing actual merchant spend stops at Rs 300; late redeemers after #12 are declined and logged in refused_redemptions.</a:t>
+              <a:t>Pass terms state 'valid while shop offer budget lasts'; declining a 13th regular still risks counter disappointment, so overrun alerts, 80%-cap top-up prompts, and logged declines are mandatory.</a:t>
             </a:r>
           </a:p>
           <a:p>
@@ -20152,7 +20168,7 @@
               <a:buChar char="•"/>
             </a:pPr>
             <a:r>
-              <a:rPr sz="1140" b="1">
+              <a:rPr sz="1120" b="1">
                 <a:solidFill>
                   <a:srgbClr val="002970"/>
                 </a:solidFill>
@@ -20161,7 +20177,7 @@
               <a:t>Automated Concurrency &amp; ITT Tests: </a:t>
             </a:r>
             <a:r>
-              <a:rPr sz="1140" b="0">
+              <a:rPr sz="1120" b="0">
                 <a:solidFill>
                   <a:srgbClr val="0F172A"/>
                 </a:solidFill>

</xml_diff>